<commit_message>
first version of testing the ai´s
</commit_message>
<xml_diff>
--- a/plan/midpresentation.pptx
+++ b/plan/midpresentation.pptx
@@ -368,7 +368,7 @@
           <a:p>
             <a:fld id="{D59AAE17-292B-40FA-8691-962AFFA4433D}" type="datetimeFigureOut">
               <a:rPr lang="de-DE" smtClean="0"/>
-              <a:t>10.12.2025</a:t>
+              <a:t>20.12.2025</a:t>
             </a:fld>
             <a:endParaRPr lang="de-DE"/>
           </a:p>
@@ -6428,52 +6428,14 @@
             <a:pPr lvl="2"/>
             <a:r>
               <a:rPr lang="de-DE" sz="1600" dirty="0"/>
-              <a:t>Mistral-7B (Mixtral-7B ) (</a:t>
-            </a:r>
-            <a:r>
-              <a:rPr lang="de-DE" sz="1600" dirty="0" err="1"/>
-              <a:t>is</a:t>
-            </a:r>
+              <a:t>Mixtral-70B</a:t>
+            </a:r>
+          </a:p>
+          <a:p>
+            <a:pPr lvl="2"/>
             <a:r>
               <a:rPr lang="de-DE" sz="1600" dirty="0"/>
-              <a:t> </a:t>
-            </a:r>
-            <a:r>
-              <a:rPr lang="de-DE" sz="1600" dirty="0" err="1"/>
-              <a:t>there</a:t>
-            </a:r>
-            <a:r>
-              <a:rPr lang="de-DE" sz="1600" dirty="0"/>
-              <a:t> </a:t>
-            </a:r>
-            <a:r>
-              <a:rPr lang="de-DE" sz="1600" dirty="0" err="1"/>
-              <a:t>difference</a:t>
-            </a:r>
-            <a:r>
-              <a:rPr lang="de-DE" sz="1600" dirty="0"/>
-              <a:t>?)</a:t>
-            </a:r>
-          </a:p>
-          <a:p>
-            <a:pPr lvl="2"/>
-            <a:r>
-              <a:rPr lang="de-DE" sz="1600" dirty="0"/>
-              <a:t>Mistral-70B</a:t>
-            </a:r>
-          </a:p>
-          <a:p>
-            <a:pPr lvl="2"/>
-            <a:r>
-              <a:rPr lang="de-DE" sz="1600" dirty="0"/>
-              <a:t>Mistral-8*22B</a:t>
-            </a:r>
-          </a:p>
-          <a:p>
-            <a:pPr lvl="2"/>
-            <a:r>
-              <a:rPr lang="de-DE" sz="1600" dirty="0"/>
-              <a:t>Qwen2.5-7B</a:t>
+              <a:t>Mixtral-8*22B</a:t>
             </a:r>
           </a:p>
           <a:p>
@@ -6522,6 +6484,17 @@
             <a:r>
               <a:rPr lang="de-DE" sz="2000" dirty="0"/>
               <a:t> : </a:t>
+            </a:r>
+          </a:p>
+          <a:p>
+            <a:pPr lvl="2"/>
+            <a:r>
+              <a:rPr lang="de-DE" sz="1600" dirty="0" err="1"/>
+              <a:t>Deepseek</a:t>
+            </a:r>
+            <a:r>
+              <a:rPr lang="de-DE" sz="1600" dirty="0"/>
+              <a:t> R1</a:t>
             </a:r>
           </a:p>
           <a:p>

</xml_diff>